<commit_message>
AAS hello-world: clarify 'what runs today' slide (show the end-to-end loop, not just the PCF result)
</commit_message>
<xml_diff>
--- a/extras/sourceIdentifiers/aas-helloworld/aas-usd-helloworld.pptx
+++ b/extras/sourceIdentifiers/aas-helloworld/aas-usd-helloworld.pptx
@@ -5357,8 +5357,8 @@
         </p:nvSpPr>
         <p:spPr>
           <a:xfrm>
-            <a:off x="640080" y="1554480"/>
-            <a:ext cx="10972800" cy="640080"/>
+            <a:off x="640080" y="1481328"/>
+            <a:ext cx="10972800" cy="548640"/>
           </a:xfrm>
           <a:prstGeom prst="rect">
             <a:avLst/>
@@ -5372,329 +5372,27 @@
           <a:lstStyle/>
           <a:p>
             <a:r>
-              <a:rPr sz="1600" b="0" i="0">
+              <a:rPr sz="1500" b="0" i="1">
                 <a:solidFill>
                   <a:srgbClr val="A8B09C"/>
                 </a:solidFill>
                 <a:latin typeface="Segoe UI"/>
               </a:rPr>
-              <a:t>End to end against Eclipse BaSyx + its public Fraunhofer-IESE drivemotor shell:</a:t>
-            </a:r>
-          </a:p>
-        </p:txBody>
-      </p:sp>
-      <p:graphicFrame>
-        <p:nvGraphicFramePr>
-          <p:cNvPr id="5" name="Table 4"/>
-          <p:cNvGraphicFramePr>
-            <a:graphicFrameLocks noGrp="1"/>
-          </p:cNvGraphicFramePr>
-          <p:nvPr/>
-        </p:nvGraphicFramePr>
-        <p:xfrm>
-          <a:off x="640080" y="2286000"/>
-          <a:ext cx="10881360" cy="3017520"/>
-        </p:xfrm>
-        <a:graphic>
-          <a:graphicData uri="http://schemas.openxmlformats.org/drawingml/2006/table">
-            <a:tbl>
-              <a:tblPr firstRow="1" bandRow="1">
-                <a:tableStyleId>{5C22544A-7EE6-4342-B048-85BDC9FD1C3A}</a:tableStyleId>
-              </a:tblPr>
-              <a:tblGrid>
-                <a:gridCol w="5440680"/>
-                <a:gridCol w="5440680"/>
-              </a:tblGrid>
-              <a:tr h="502920">
-                <a:tc>
-                  <a:txBody>
-                    <a:bodyPr/>
-                    <a:lstStyle/>
-                    <a:p>
-                      <a:r>
-                        <a:rPr sz="1400" b="1" i="0">
-                          <a:solidFill>
-                            <a:srgbClr val="FFFFFF"/>
-                          </a:solidFill>
-                          <a:latin typeface="Segoe UI"/>
-                        </a:rPr>
-                        <a:t>EN 15804 stage</a:t>
-                      </a:r>
-                    </a:p>
-                  </a:txBody>
-                  <a:tcPr anchor="ctr">
-                    <a:solidFill>
-                      <a:srgbClr val="76B900"/>
-                    </a:solidFill>
-                  </a:tcPr>
-                </a:tc>
-                <a:tc>
-                  <a:txBody>
-                    <a:bodyPr/>
-                    <a:lstStyle/>
-                    <a:p>
-                      <a:r>
-                        <a:rPr sz="1400" b="1" i="0">
-                          <a:solidFill>
-                            <a:srgbClr val="FFFFFF"/>
-                          </a:solidFill>
-                          <a:latin typeface="Segoe UI"/>
-                        </a:rPr>
-                        <a:t>kg CO₂e / piece</a:t>
-                      </a:r>
-                    </a:p>
-                  </a:txBody>
-                  <a:tcPr anchor="ctr">
-                    <a:solidFill>
-                      <a:srgbClr val="76B900"/>
-                    </a:solidFill>
-                  </a:tcPr>
-                </a:tc>
-              </a:tr>
-              <a:tr h="502920">
-                <a:tc>
-                  <a:txBody>
-                    <a:bodyPr/>
-                    <a:lstStyle/>
-                    <a:p>
-                      <a:r>
-                        <a:rPr sz="1300" b="0" i="0">
-                          <a:solidFill>
-                            <a:srgbClr val="ECECEC"/>
-                          </a:solidFill>
-                          <a:latin typeface="Segoe UI"/>
-                        </a:rPr>
-                        <a:t>A1 — raw materials</a:t>
-                      </a:r>
-                    </a:p>
-                  </a:txBody>
-                  <a:tcPr anchor="ctr" marT="38100" marB="38100">
-                    <a:solidFill>
-                      <a:srgbClr val="262626"/>
-                    </a:solidFill>
-                  </a:tcPr>
-                </a:tc>
-                <a:tc>
-                  <a:txBody>
-                    <a:bodyPr/>
-                    <a:lstStyle/>
-                    <a:p>
-                      <a:r>
-                        <a:rPr sz="1300" b="0" i="0">
-                          <a:solidFill>
-                            <a:srgbClr val="ECECEC"/>
-                          </a:solidFill>
-                          <a:latin typeface="Segoe UI"/>
-                        </a:rPr>
-                        <a:t>180</a:t>
-                      </a:r>
-                    </a:p>
-                  </a:txBody>
-                  <a:tcPr anchor="ctr" marT="38100" marB="38100">
-                    <a:solidFill>
-                      <a:srgbClr val="262626"/>
-                    </a:solidFill>
-                  </a:tcPr>
-                </a:tc>
-              </a:tr>
-              <a:tr h="502920">
-                <a:tc>
-                  <a:txBody>
-                    <a:bodyPr/>
-                    <a:lstStyle/>
-                    <a:p>
-                      <a:r>
-                        <a:rPr sz="1300" b="0" i="0">
-                          <a:solidFill>
-                            <a:srgbClr val="ECECEC"/>
-                          </a:solidFill>
-                          <a:latin typeface="Segoe UI"/>
-                        </a:rPr>
-                        <a:t>A2 — transport</a:t>
-                      </a:r>
-                    </a:p>
-                  </a:txBody>
-                  <a:tcPr anchor="ctr" marT="38100" marB="38100">
-                    <a:solidFill>
-                      <a:srgbClr val="202020"/>
-                    </a:solidFill>
-                  </a:tcPr>
-                </a:tc>
-                <a:tc>
-                  <a:txBody>
-                    <a:bodyPr/>
-                    <a:lstStyle/>
-                    <a:p>
-                      <a:r>
-                        <a:rPr sz="1300" b="0" i="0">
-                          <a:solidFill>
-                            <a:srgbClr val="ECECEC"/>
-                          </a:solidFill>
-                          <a:latin typeface="Segoe UI"/>
-                        </a:rPr>
-                        <a:t>25</a:t>
-                      </a:r>
-                    </a:p>
-                  </a:txBody>
-                  <a:tcPr anchor="ctr" marT="38100" marB="38100">
-                    <a:solidFill>
-                      <a:srgbClr val="202020"/>
-                    </a:solidFill>
-                  </a:tcPr>
-                </a:tc>
-              </a:tr>
-              <a:tr h="502920">
-                <a:tc>
-                  <a:txBody>
-                    <a:bodyPr/>
-                    <a:lstStyle/>
-                    <a:p>
-                      <a:r>
-                        <a:rPr sz="1300" b="0" i="0">
-                          <a:solidFill>
-                            <a:srgbClr val="ECECEC"/>
-                          </a:solidFill>
-                          <a:latin typeface="Segoe UI"/>
-                        </a:rPr>
-                        <a:t>A3 — manufacturing</a:t>
-                      </a:r>
-                    </a:p>
-                  </a:txBody>
-                  <a:tcPr anchor="ctr" marT="38100" marB="38100">
-                    <a:solidFill>
-                      <a:srgbClr val="262626"/>
-                    </a:solidFill>
-                  </a:tcPr>
-                </a:tc>
-                <a:tc>
-                  <a:txBody>
-                    <a:bodyPr/>
-                    <a:lstStyle/>
-                    <a:p>
-                      <a:r>
-                        <a:rPr sz="1300" b="0" i="0">
-                          <a:solidFill>
-                            <a:srgbClr val="ECECEC"/>
-                          </a:solidFill>
-                          <a:latin typeface="Segoe UI"/>
-                        </a:rPr>
-                        <a:t>80</a:t>
-                      </a:r>
-                    </a:p>
-                  </a:txBody>
-                  <a:tcPr anchor="ctr" marT="38100" marB="38100">
-                    <a:solidFill>
-                      <a:srgbClr val="262626"/>
-                    </a:solidFill>
-                  </a:tcPr>
-                </a:tc>
-              </a:tr>
-              <a:tr h="502920">
-                <a:tc>
-                  <a:txBody>
-                    <a:bodyPr/>
-                    <a:lstStyle/>
-                    <a:p>
-                      <a:r>
-                        <a:rPr sz="1300" b="1" i="0">
-                          <a:solidFill>
-                            <a:srgbClr val="76B900"/>
-                          </a:solidFill>
-                          <a:latin typeface="Segoe UI"/>
-                        </a:rPr>
-                        <a:t>Cradle-to-gate (A1–A3)</a:t>
-                      </a:r>
-                    </a:p>
-                  </a:txBody>
-                  <a:tcPr anchor="ctr" marT="38100" marB="38100">
-                    <a:solidFill>
-                      <a:srgbClr val="333D22"/>
-                    </a:solidFill>
-                  </a:tcPr>
-                </a:tc>
-                <a:tc>
-                  <a:txBody>
-                    <a:bodyPr/>
-                    <a:lstStyle/>
-                    <a:p>
-                      <a:r>
-                        <a:rPr sz="1300" b="1" i="0">
-                          <a:solidFill>
-                            <a:srgbClr val="ECECEC"/>
-                          </a:solidFill>
-                          <a:latin typeface="Segoe UI"/>
-                        </a:rPr>
-                        <a:t>285   ✓ complete</a:t>
-                      </a:r>
-                    </a:p>
-                  </a:txBody>
-                  <a:tcPr anchor="ctr" marT="38100" marB="38100">
-                    <a:solidFill>
-                      <a:srgbClr val="333D22"/>
-                    </a:solidFill>
-                  </a:tcPr>
-                </a:tc>
-              </a:tr>
-              <a:tr h="502920">
-                <a:tc>
-                  <a:txBody>
-                    <a:bodyPr/>
-                    <a:lstStyle/>
-                    <a:p>
-                      <a:r>
-                        <a:rPr sz="1300" b="0" i="0">
-                          <a:solidFill>
-                            <a:srgbClr val="ECECEC"/>
-                          </a:solidFill>
-                          <a:latin typeface="Segoe UI"/>
-                        </a:rPr>
-                        <a:t>Use (B*), end-of-life (C*)</a:t>
-                      </a:r>
-                    </a:p>
-                  </a:txBody>
-                  <a:tcPr anchor="ctr" marT="38100" marB="38100">
-                    <a:solidFill>
-                      <a:srgbClr val="262626"/>
-                    </a:solidFill>
-                  </a:tcPr>
-                </a:tc>
-                <a:tc>
-                  <a:txBody>
-                    <a:bodyPr/>
-                    <a:lstStyle/>
-                    <a:p>
-                      <a:r>
-                        <a:rPr sz="1300" b="0" i="0">
-                          <a:solidFill>
-                            <a:srgbClr val="ECECEC"/>
-                          </a:solidFill>
-                          <a:latin typeface="Segoe UI"/>
-                        </a:rPr>
-                        <a:t>not reported — flagged</a:t>
-                      </a:r>
-                    </a:p>
-                  </a:txBody>
-                  <a:tcPr anchor="ctr" marT="38100" marB="38100">
-                    <a:solidFill>
-                      <a:srgbClr val="262626"/>
-                    </a:solidFill>
-                  </a:tcPr>
-                </a:tc>
-              </a:tr>
-            </a:tbl>
-          </a:graphicData>
-        </a:graphic>
-      </p:graphicFrame>
-      <p:sp>
-        <p:nvSpPr>
-          <p:cNvPr id="6" name="TextBox 5"/>
+              <a:t>One end-to-end loop, against Eclipse BaSyx + its public Fraunhofer-IESE drivemotor shell:</a:t>
+            </a:r>
+          </a:p>
+        </p:txBody>
+      </p:sp>
+      <p:sp>
+        <p:nvSpPr>
+          <p:cNvPr id="5" name="TextBox 4"/>
           <p:cNvSpPr txBox="1"/>
           <p:nvPr/>
         </p:nvSpPr>
         <p:spPr>
           <a:xfrm>
-            <a:off x="640080" y="5440680"/>
-            <a:ext cx="10881360" cy="1097280"/>
+            <a:off x="640080" y="2057400"/>
+            <a:ext cx="10972800" cy="2743200"/>
           </a:xfrm>
           <a:prstGeom prst="rect">
             <a:avLst/>
@@ -5707,14 +5405,246 @@
           </a:bodyPr>
           <a:lstStyle/>
           <a:p>
-            <a:r>
-              <a:rPr sz="1400" b="0" i="1">
+            <a:pPr>
+              <a:spcAft>
+                <a:spcPts val="300"/>
+              </a:spcAft>
+            </a:pPr>
+            <a:r>
+              <a:rPr sz="1600" b="1" i="0">
+                <a:solidFill>
+                  <a:srgbClr val="76B900"/>
+                </a:solidFill>
+                <a:latin typeface="Segoe UI"/>
+              </a:rPr>
+              <a:t>1  </a:t>
+            </a:r>
+            <a:r>
+              <a:rPr sz="1600" b="1" i="0">
+                <a:solidFill>
+                  <a:srgbClr val="ECECEC"/>
+                </a:solidFill>
+                <a:latin typeface="Segoe UI"/>
+              </a:rPr>
+              <a:t>Author identity-only USD</a:t>
+            </a:r>
+          </a:p>
+          <a:p>
+            <a:pPr lvl="1">
+              <a:spcAft>
+                <a:spcPts val="900"/>
+              </a:spcAft>
+            </a:pPr>
+            <a:r>
+              <a:rPr sz="1250" b="0" i="0">
                 <a:solidFill>
                   <a:srgbClr val="A8B09C"/>
                 </a:solidFill>
-                <a:latin typeface="Segoe UI"/>
-              </a:rPr>
-              <a:t>CarbonFootprint submodel (IDTA 02023); fields located by semanticId, robust to idShort variation. Nothing written back into USD — the roll-up is computed in the consumer.</a:t>
+                <a:latin typeface="Consolas"/>
+              </a:rPr>
+              <a:t>      drivemotor.usda — a prim carrying ONLY the globalAssetId. No data, no endpoints.</a:t>
+            </a:r>
+          </a:p>
+          <a:p>
+            <a:pPr>
+              <a:spcAft>
+                <a:spcPts val="300"/>
+              </a:spcAft>
+            </a:pPr>
+            <a:r>
+              <a:rPr sz="1600" b="1" i="0">
+                <a:solidFill>
+                  <a:srgbClr val="76B900"/>
+                </a:solidFill>
+                <a:latin typeface="Segoe UI"/>
+              </a:rPr>
+              <a:t>2  </a:t>
+            </a:r>
+            <a:r>
+              <a:rPr sz="1600" b="1" i="0">
+                <a:solidFill>
+                  <a:srgbClr val="ECECEC"/>
+                </a:solidFill>
+                <a:latin typeface="Segoe UI"/>
+              </a:rPr>
+              <a:t>Resolve at runtime</a:t>
+            </a:r>
+          </a:p>
+          <a:p>
+            <a:pPr lvl="1">
+              <a:spcAft>
+                <a:spcPts val="900"/>
+              </a:spcAft>
+            </a:pPr>
+            <a:r>
+              <a:rPr sz="1250" b="0" i="0">
+                <a:solidFill>
+                  <a:srgbClr val="A8B09C"/>
+                </a:solidFill>
+                <a:latin typeface="Consolas"/>
+              </a:rPr>
+              <a:t>      read the id off the prim  →  inject the endpoint (not from USD)  →  Discovery → Registry → Repository  →  live shell + submodels</a:t>
+            </a:r>
+          </a:p>
+          <a:p>
+            <a:pPr>
+              <a:spcAft>
+                <a:spcPts val="300"/>
+              </a:spcAft>
+            </a:pPr>
+            <a:r>
+              <a:rPr sz="1600" b="1" i="0">
+                <a:solidFill>
+                  <a:srgbClr val="76B900"/>
+                </a:solidFill>
+                <a:latin typeface="Segoe UI"/>
+              </a:rPr>
+              <a:t>3  </a:t>
+            </a:r>
+            <a:r>
+              <a:rPr sz="1600" b="1" i="0">
+                <a:solidFill>
+                  <a:srgbClr val="ECECEC"/>
+                </a:solidFill>
+                <a:latin typeface="Segoe UI"/>
+              </a:rPr>
+              <a:t>Do useful work with the live data</a:t>
+            </a:r>
+          </a:p>
+          <a:p>
+            <a:pPr lvl="1">
+              <a:spcAft>
+                <a:spcPts val="900"/>
+              </a:spcAft>
+            </a:pPr>
+            <a:r>
+              <a:rPr sz="1250" b="0" i="0">
+                <a:solidFill>
+                  <a:srgbClr val="A8B09C"/>
+                </a:solidFill>
+                <a:latin typeface="Consolas"/>
+              </a:rPr>
+              <a:t>      parse the CarbonFootprint submodel (IDTA 02023)  →  roll up the footprint, flag what's missing</a:t>
+            </a:r>
+          </a:p>
+          <a:p>
+            <a:pPr>
+              <a:spcAft>
+                <a:spcPts val="300"/>
+              </a:spcAft>
+            </a:pPr>
+            <a:r>
+              <a:rPr sz="1600" b="1" i="0">
+                <a:solidFill>
+                  <a:srgbClr val="76B900"/>
+                </a:solidFill>
+                <a:latin typeface="Segoe UI"/>
+              </a:rPr>
+              <a:t>4  </a:t>
+            </a:r>
+            <a:r>
+              <a:rPr sz="1600" b="1" i="0">
+                <a:solidFill>
+                  <a:srgbClr val="ECECEC"/>
+                </a:solidFill>
+                <a:latin typeface="Segoe UI"/>
+              </a:rPr>
+              <a:t>Nothing mirrored back</a:t>
+            </a:r>
+          </a:p>
+          <a:p>
+            <a:pPr lvl="1">
+              <a:spcAft>
+                <a:spcPts val="900"/>
+              </a:spcAft>
+            </a:pPr>
+            <a:r>
+              <a:rPr sz="1250" b="0" i="0">
+                <a:solidFill>
+                  <a:srgbClr val="A8B09C"/>
+                </a:solidFill>
+                <a:latin typeface="Consolas"/>
+              </a:rPr>
+              <a:t>      the result is computed in the consumer; the USD file is never touched</a:t>
+            </a:r>
+          </a:p>
+        </p:txBody>
+      </p:sp>
+      <p:sp>
+        <p:nvSpPr>
+          <p:cNvPr id="6" name="Rectangle 5"/>
+          <p:cNvSpPr/>
+          <p:nvPr/>
+        </p:nvSpPr>
+        <p:spPr>
+          <a:xfrm>
+            <a:off x="640080" y="5413248"/>
+            <a:ext cx="10881360" cy="1078992"/>
+          </a:xfrm>
+          <a:prstGeom prst="rect">
+            <a:avLst/>
+          </a:prstGeom>
+          <a:solidFill>
+            <a:srgbClr val="2C361B"/>
+          </a:solidFill>
+          <a:ln w="19050">
+            <a:solidFill>
+              <a:srgbClr val="76B900"/>
+            </a:solidFill>
+          </a:ln>
+        </p:spPr>
+        <p:style>
+          <a:lnRef idx="1">
+            <a:schemeClr val="accent1"/>
+          </a:lnRef>
+          <a:fillRef idx="3">
+            <a:schemeClr val="accent1"/>
+          </a:fillRef>
+          <a:effectRef idx="2">
+            <a:schemeClr val="accent1"/>
+          </a:effectRef>
+          <a:fontRef idx="minor">
+            <a:schemeClr val="lt1"/>
+          </a:fontRef>
+        </p:style>
+        <p:txBody>
+          <a:bodyPr rtlCol="0" anchor="ctr" wrap="square" lIns="228600" tIns="73152"/>
+          <a:lstStyle/>
+          <a:p>
+            <a:pPr algn="l"/>
+            <a:r>
+              <a:rPr sz="1300" b="1" i="0">
+                <a:solidFill>
+                  <a:srgbClr val="76B900"/>
+                </a:solidFill>
+                <a:latin typeface="Segoe UI"/>
+              </a:rPr>
+              <a:t>Result  </a:t>
+            </a:r>
+            <a:r>
+              <a:rPr sz="1500" b="1" i="0">
+                <a:solidFill>
+                  <a:srgbClr val="FFFFFF"/>
+                </a:solidFill>
+                <a:latin typeface="Segoe UI"/>
+              </a:rPr>
+              <a:t>A USD asset carrying only an ID produced a live analysis — nothing copied into the scene.</a:t>
+            </a:r>
+          </a:p>
+          <a:p>
+            <a:pPr algn="l">
+              <a:spcBef>
+                <a:spcPts val="300"/>
+              </a:spcBef>
+            </a:pPr>
+            <a:r>
+              <a:rPr sz="1300" b="0" i="0">
+                <a:solidFill>
+                  <a:srgbClr val="ECECEC"/>
+                </a:solidFill>
+                <a:latin typeface="Segoe UI"/>
+              </a:rPr>
+              <a:t>Cradle-to-gate  A1 180 + A2 25 + A3 80 = 285 kg CO₂e/piece ✓   ·   use (B*) &amp; end-of-life (C*) not reported → flagged</a:t>
             </a:r>
           </a:p>
         </p:txBody>

</xml_diff>

<commit_message>
AAS hello-world: add 'what this gives a carbon-reduction effort' slide (measurement-and-targeting value; honest teeth-at-assembly-scale caveat)
</commit_message>
<xml_diff>
--- a/extras/sourceIdentifiers/aas-helloworld/aas-usd-helloworld.pptx
+++ b/extras/sourceIdentifiers/aas-helloworld/aas-usd-helloworld.pptx
@@ -5747,7 +5747,7 @@
                 </a:solidFill>
                 <a:latin typeface="Segoe UI"/>
               </a:rPr>
-              <a:t>Why gap-flagging is the point</a:t>
+              <a:t>What this gives a carbon-reduction effort</a:t>
             </a:r>
           </a:p>
         </p:txBody>
@@ -5761,7 +5761,7 @@
         <p:spPr>
           <a:xfrm>
             <a:off x="640080" y="1600200"/>
-            <a:ext cx="10972800" cy="5074920"/>
+            <a:ext cx="10972800" cy="822960"/>
           </a:xfrm>
           <a:prstGeom prst="rect">
             <a:avLst/>
@@ -5774,6 +5774,40 @@
           </a:bodyPr>
           <a:lstStyle/>
           <a:p>
+            <a:r>
+              <a:rPr sz="1600" b="0" i="1">
+                <a:solidFill>
+                  <a:srgbClr val="A8B09C"/>
+                </a:solidFill>
+                <a:latin typeface="Segoe UI"/>
+              </a:rPr>
+              <a:t>The prototype doesn't cut carbon — it produces the information a reduction effort runs on:</a:t>
+            </a:r>
+          </a:p>
+        </p:txBody>
+      </p:sp>
+      <p:sp>
+        <p:nvSpPr>
+          <p:cNvPr id="5" name="TextBox 4"/>
+          <p:cNvSpPr txBox="1"/>
+          <p:nvPr/>
+        </p:nvSpPr>
+        <p:spPr>
+          <a:xfrm>
+            <a:off x="640080" y="2377440"/>
+            <a:ext cx="10972800" cy="4297680"/>
+          </a:xfrm>
+          <a:prstGeom prst="rect">
+            <a:avLst/>
+          </a:prstGeom>
+          <a:noFill/>
+        </p:spPr>
+        <p:txBody>
+          <a:bodyPr wrap="square">
+            <a:spAutoFit/>
+          </a:bodyPr>
+          <a:lstStyle/>
+          <a:p>
             <a:pPr>
               <a:spcAft>
                 <a:spcPts val="1000"/>
@@ -5795,7 +5829,7 @@
                 </a:solidFill>
                 <a:latin typeface="Segoe UI"/>
               </a:rPr>
-              <a:t>A report-grade roll-up must tell “footprint is zero” apart from “never reported a footprint.”</a:t>
+              <a:t>A credible baseline</a:t>
             </a:r>
           </a:p>
           <a:p>
@@ -5811,7 +5845,7 @@
                 </a:solidFill>
                 <a:latin typeface="Segoe UI"/>
               </a:rPr>
-              <a:t>Coverage is a first-class output: sum only the stages reported; name what's missing.</a:t>
+              <a:t>a trustworthy total — missing data flagged, never silently zeroed — the number you measure reductions against.</a:t>
             </a:r>
           </a:p>
           <a:p>
@@ -5836,7 +5870,7 @@
                 </a:solidFill>
                 <a:latin typeface="Segoe UI"/>
               </a:rPr>
-              <a:t>A missing value is never silently coerced to zero.</a:t>
+              <a:t>Hotspot ranking — where the carbon actually is</a:t>
             </a:r>
           </a:p>
           <a:p>
@@ -5852,7 +5886,7 @@
                 </a:solidFill>
                 <a:latin typeface="Segoe UI"/>
               </a:rPr>
-              <a:t>Missing PCF, missing CO₂e, incomplete cradle-to-gate, unreported use phase — each is flagged.</a:t>
+              <a:t>the per-component and per-stage split (materials / transport / manufacturing) → target the parts that dominate, not everything at once.</a:t>
             </a:r>
           </a:p>
           <a:p>
@@ -5877,7 +5911,7 @@
                 </a:solidFill>
                 <a:latin typeface="Segoe UI"/>
               </a:rPr>
-              <a:t>Gaps are actionable — they tell you which supplier to chase.</a:t>
+              <a:t>A supplier accountability list</a:t>
             </a:r>
           </a:p>
           <a:p>
@@ -5893,7 +5927,82 @@
                 </a:solidFill>
                 <a:latin typeface="Segoe UI"/>
               </a:rPr>
-              <a:t>The roll-up sums across components, so it extends directly to a bill of materials.</a:t>
+              <a:t>names who hasn't reported — who to chase to complete the picture, and the lever to ask for lower-carbon alternatives.</a:t>
+            </a:r>
+          </a:p>
+          <a:p>
+            <a:pPr>
+              <a:spcAft>
+                <a:spcPts val="1000"/>
+              </a:spcAft>
+            </a:pPr>
+            <a:r>
+              <a:rPr sz="1800" b="1" i="0">
+                <a:solidFill>
+                  <a:srgbClr val="76B900"/>
+                </a:solidFill>
+                <a:latin typeface="Segoe UI"/>
+              </a:rPr>
+              <a:t>▍ </a:t>
+            </a:r>
+            <a:r>
+              <a:rPr sz="1800" b="1" i="0">
+                <a:solidFill>
+                  <a:srgbClr val="ECECEC"/>
+                </a:solidFill>
+                <a:latin typeface="Segoe UI"/>
+              </a:rPr>
+              <a:t>A live feedback loop</a:t>
+            </a:r>
+          </a:p>
+          <a:p>
+            <a:pPr lvl="1">
+              <a:spcAft>
+                <a:spcPts val="1200"/>
+              </a:spcAft>
+            </a:pPr>
+            <a:r>
+              <a:rPr sz="1450" b="0" i="0">
+                <a:solidFill>
+                  <a:srgbClr val="A8B09C"/>
+                </a:solidFill>
+                <a:latin typeface="Segoe UI"/>
+              </a:rPr>
+              <a:t>pulled from source, so a greener material or supplier shows up in the roll-up automatically — you can prove a change worked.</a:t>
+            </a:r>
+          </a:p>
+        </p:txBody>
+      </p:sp>
+      <p:sp>
+        <p:nvSpPr>
+          <p:cNvPr id="6" name="TextBox 5"/>
+          <p:cNvSpPr txBox="1"/>
+          <p:nvPr/>
+        </p:nvSpPr>
+        <p:spPr>
+          <a:xfrm>
+            <a:off x="640080" y="5897880"/>
+            <a:ext cx="10972800" cy="731520"/>
+          </a:xfrm>
+          <a:prstGeom prst="rect">
+            <a:avLst/>
+          </a:prstGeom>
+          <a:noFill/>
+        </p:spPr>
+        <p:txBody>
+          <a:bodyPr wrap="square">
+            <a:spAutoFit/>
+          </a:bodyPr>
+          <a:lstStyle/>
+          <a:p>
+            <a:r>
+              <a:rPr sz="1300" b="0" i="1">
+                <a:solidFill>
+                  <a:srgbClr val="A8B09C"/>
+                </a:solidFill>
+                <a:latin typeface="Segoe UI"/>
+              </a:rPr>
+              <a:t>Targeting teeth show at assembly scale (the bill-of-materials step, next). The single component proves the mechanism — live, trustworthy, gap-aware.</a:t>
             </a:r>
           </a:p>
         </p:txBody>

</xml_diff>